<commit_message>
feat: finalize presentation update with Gemini 3.1 AI persona and refined daily routine
</commit_message>
<xml_diff>
--- a/LunchBot_Deck.pptx
+++ b/LunchBot_Deck.pptx
@@ -1,21 +1,35 @@
 
 <file path=ppt/presentation.xml><?xml version="1.0" encoding="utf-8"?>
-<p:presentation xmlns:a="http://schemas.openxmlformats.org/drawingml/2006/main" xmlns:r="http://schemas.openxmlformats.org/officeDocument/2006/relationships" xmlns:p="http://schemas.openxmlformats.org/presentationml/2006/main" saveSubsetFonts="1" autoCompressPictures="0">
+<p:presentation xmlns:a="http://schemas.openxmlformats.org/drawingml/2006/main" xmlns:r="http://schemas.openxmlformats.org/officeDocument/2006/relationships" xmlns:p="http://schemas.openxmlformats.org/presentationml/2006/main" embedTrueTypeFonts="1" saveSubsetFonts="1" autoCompressPictures="0">
   <p:sldMasterIdLst>
     <p:sldMasterId id="2147483648" r:id="rId1"/>
   </p:sldMasterIdLst>
+  <p:notesMasterIdLst>
+    <p:notesMasterId r:id="rId8"/>
+  </p:notesMasterIdLst>
   <p:sldIdLst>
     <p:sldId id="256" r:id="rId2"/>
     <p:sldId id="257" r:id="rId3"/>
-    <p:sldId id="258" r:id="rId4"/>
-    <p:sldId id="259" r:id="rId5"/>
-    <p:sldId id="260" r:id="rId6"/>
+    <p:sldId id="261" r:id="rId4"/>
+    <p:sldId id="258" r:id="rId5"/>
+    <p:sldId id="259" r:id="rId6"/>
+    <p:sldId id="260" r:id="rId7"/>
   </p:sldIdLst>
-  <p:notesMasterIdLst>
-    <p:notesMasterId r:id="rId7"/>
-  </p:notesMasterIdLst>
-  <p:sldSz cx="9144000" cy="5143500"/>
+  <p:sldSz cx="9144000" cy="5143500" type="screen16x9"/>
   <p:notesSz cx="5143500" cy="9144000"/>
+  <p:embeddedFontLst>
+    <p:embeddedFont>
+      <p:font typeface="Arial Black" panose="020B0A04020102020204" pitchFamily="34" charset="0"/>
+      <p:bold r:id="rId9"/>
+    </p:embeddedFont>
+    <p:embeddedFont>
+      <p:font typeface="Calibri" panose="020F0502020204030204" pitchFamily="34" charset="0"/>
+      <p:regular r:id="rId10"/>
+      <p:bold r:id="rId11"/>
+      <p:italic r:id="rId12"/>
+      <p:boldItalic r:id="rId13"/>
+    </p:embeddedFont>
+  </p:embeddedFontLst>
   <p:defaultTextStyle>
     <a:lvl1pPr marL="0" algn="l" defTabSz="914400" rtl="0" eaLnBrk="1" latinLnBrk="0" hangingPunct="1">
       <a:defRPr sz="1800" kern="1200">
@@ -108,6 +122,11 @@
       </a:defRPr>
     </a:lvl9pPr>
   </p:defaultTextStyle>
+  <p:extLst>
+    <p:ext uri="{EFAFB233-063F-42B5-8137-9DF3F51BA10A}">
+      <p15:sldGuideLst xmlns:p15="http://schemas.microsoft.com/office/powerpoint/2012/main"/>
+    </p:ext>
+  </p:extLst>
 </p:presentation>
 </file>
 
@@ -133,234 +152,10 @@
           <a:chExt cx="0" cy="0"/>
         </a:xfrm>
       </p:grpSpPr>
-      <p:sp>
-        <p:nvSpPr>
-          <p:cNvPr id="2" name="Header Placeholder 1"/>
-          <p:cNvSpPr>
-            <a:spLocks noGrp="1"/>
-          </p:cNvSpPr>
-          <p:nvPr>
-            <p:ph type="hdr" sz="quarter"/>
-          </p:nvPr>
-        </p:nvSpPr>
-        <p:spPr>
-          <a:xfrm>
-            <a:off x="0" y="0"/>
-            <a:ext cx="2971800" cy="458788"/>
-          </a:xfrm>
-          <a:prstGeom prst="rect">
-            <a:avLst/>
-          </a:prstGeom>
-        </p:spPr>
-        <p:txBody>
-          <a:bodyPr vert="horz" lIns="91440" tIns="45720" rIns="91440" bIns="45720" rtlCol="0"/>
-          <a:lstStyle>
-            <a:lvl1pPr algn="l">
-              <a:defRPr sz="1200"/>
-            </a:lvl1pPr>
-          </a:lstStyle>
-          <a:p>
-            <a:endParaRPr lang="en-US"/>
-          </a:p>
-        </p:txBody>
-      </p:sp>
-      <p:sp>
-        <p:nvSpPr>
-          <p:cNvPr id="3" name="Date Placeholder 2"/>
-          <p:cNvSpPr>
-            <a:spLocks noGrp="1"/>
-          </p:cNvSpPr>
-          <p:nvPr>
-            <p:ph type="dt" idx="1"/>
-          </p:nvPr>
-        </p:nvSpPr>
-        <p:spPr>
-          <a:xfrm>
-            <a:off x="3884613" y="0"/>
-            <a:ext cx="2971800" cy="458788"/>
-          </a:xfrm>
-          <a:prstGeom prst="rect">
-            <a:avLst/>
-          </a:prstGeom>
-        </p:spPr>
-        <p:txBody>
-          <a:bodyPr vert="horz" lIns="91440" tIns="45720" rIns="91440" bIns="45720" rtlCol="0"/>
-          <a:lstStyle>
-            <a:lvl1pPr algn="r">
-              <a:defRPr sz="1200"/>
-            </a:lvl1pPr>
-          </a:lstStyle>
-          <a:p>
-            <a:fld id="{5282F153-3F37-0F45-9E97-73ACFA13230C}" type="datetimeFigureOut">
-              <a:rPr lang="en-US"/>
-              <a:t>7/23/19</a:t>
-            </a:fld>
-            <a:endParaRPr lang="en-US"/>
-          </a:p>
-        </p:txBody>
-      </p:sp>
-      <p:sp>
-        <p:nvSpPr>
-          <p:cNvPr id="4" name="Slide Image Placeholder 3"/>
-          <p:cNvSpPr>
-            <a:spLocks noGrp="1" noRot="1" noChangeAspect="1"/>
-          </p:cNvSpPr>
-          <p:nvPr>
-            <p:ph type="sldImg" idx="2"/>
-          </p:nvPr>
-        </p:nvSpPr>
-        <p:spPr>
-          <a:xfrm>
-            <a:off x="685800" y="1143000"/>
-            <a:ext cx="5486400" cy="3086100"/>
-          </a:xfrm>
-          <a:prstGeom prst="rect">
-            <a:avLst/>
-          </a:prstGeom>
-          <a:noFill/>
-          <a:ln w="12700">
-            <a:solidFill>
-              <a:prstClr val="black"/>
-            </a:solidFill>
-          </a:ln>
-        </p:spPr>
-        <p:txBody>
-          <a:bodyPr vert="horz" lIns="91440" tIns="45720" rIns="91440" bIns="45720" rtlCol="0" anchor="ctr"/>
-          <a:lstStyle/>
-          <a:p>
-            <a:endParaRPr lang="en-US"/>
-          </a:p>
-        </p:txBody>
-      </p:sp>
-      <p:sp>
-        <p:nvSpPr>
-          <p:cNvPr id="5" name="Notes Placeholder 4"/>
-          <p:cNvSpPr>
-            <a:spLocks noGrp="1"/>
-          </p:cNvSpPr>
-          <p:nvPr>
-            <p:ph type="body" sz="quarter" idx="3"/>
-          </p:nvPr>
-        </p:nvSpPr>
-        <p:spPr>
-          <a:xfrm>
-            <a:off x="685800" y="4400550"/>
-            <a:ext cx="5486400" cy="3600450"/>
-          </a:xfrm>
-          <a:prstGeom prst="rect">
-            <a:avLst/>
-          </a:prstGeom>
-        </p:spPr>
-        <p:txBody>
-          <a:bodyPr vert="horz" lIns="91440" tIns="45720" rIns="91440" bIns="45720" rtlCol="0"/>
-          <a:lstStyle/>
-          <a:p>
-            <a:pPr lvl="0"/>
-            <a:r>
-              <a:rPr lang="en-US"/>
-              <a:t>Click to edit Master text styles</a:t>
-            </a:r>
-          </a:p>
-          <a:p>
-            <a:pPr lvl="1"/>
-            <a:r>
-              <a:rPr lang="en-US"/>
-              <a:t>Second level</a:t>
-            </a:r>
-          </a:p>
-          <a:p>
-            <a:pPr lvl="2"/>
-            <a:r>
-              <a:rPr lang="en-US"/>
-              <a:t>Third level</a:t>
-            </a:r>
-          </a:p>
-          <a:p>
-            <a:pPr lvl="3"/>
-            <a:r>
-              <a:rPr lang="en-US"/>
-              <a:t>Fourth level</a:t>
-            </a:r>
-          </a:p>
-          <a:p>
-            <a:pPr lvl="4"/>
-            <a:r>
-              <a:rPr lang="en-US"/>
-              <a:t>Fifth level</a:t>
-            </a:r>
-          </a:p>
-        </p:txBody>
-      </p:sp>
-      <p:sp>
-        <p:nvSpPr>
-          <p:cNvPr id="6" name="Footer Placeholder 5"/>
-          <p:cNvSpPr>
-            <a:spLocks noGrp="1"/>
-          </p:cNvSpPr>
-          <p:nvPr>
-            <p:ph type="ftr" sz="quarter" idx="4"/>
-          </p:nvPr>
-        </p:nvSpPr>
-        <p:spPr>
-          <a:xfrm>
-            <a:off x="0" y="8685213"/>
-            <a:ext cx="2971800" cy="458787"/>
-          </a:xfrm>
-          <a:prstGeom prst="rect">
-            <a:avLst/>
-          </a:prstGeom>
-        </p:spPr>
-        <p:txBody>
-          <a:bodyPr vert="horz" lIns="91440" tIns="45720" rIns="91440" bIns="45720" rtlCol="0" anchor="b"/>
-          <a:lstStyle>
-            <a:lvl1pPr algn="l">
-              <a:defRPr sz="1200"/>
-            </a:lvl1pPr>
-          </a:lstStyle>
-          <a:p>
-            <a:endParaRPr lang="en-US"/>
-          </a:p>
-        </p:txBody>
-      </p:sp>
-      <p:sp>
-        <p:nvSpPr>
-          <p:cNvPr id="7" name="Slide Number Placeholder 6"/>
-          <p:cNvSpPr>
-            <a:spLocks noGrp="1"/>
-          </p:cNvSpPr>
-          <p:nvPr>
-            <p:ph type="sldNum" sz="quarter" idx="5"/>
-          </p:nvPr>
-        </p:nvSpPr>
-        <p:spPr>
-          <a:xfrm>
-            <a:off x="3884613" y="8685213"/>
-            <a:ext cx="2971800" cy="458787"/>
-          </a:xfrm>
-          <a:prstGeom prst="rect">
-            <a:avLst/>
-          </a:prstGeom>
-        </p:spPr>
-        <p:txBody>
-          <a:bodyPr vert="horz" lIns="91440" tIns="45720" rIns="91440" bIns="45720" rtlCol="0" anchor="b"/>
-          <a:lstStyle>
-            <a:lvl1pPr algn="r">
-              <a:defRPr sz="1200"/>
-            </a:lvl1pPr>
-          </a:lstStyle>
-          <a:p>
-            <a:fld id="{CE5E9CC1-C706-0F49-92D6-E571CC5EEA8F}" type="slidenum">
-              <a:rPr lang="en-US"/>
-              <a:t>‹#›</a:t>
-            </a:fld>
-            <a:endParaRPr lang="en-US"/>
-          </a:p>
-        </p:txBody>
-      </p:sp>
     </p:spTree>
     <p:extLst>
       <p:ext uri="{BB962C8B-B14F-4D97-AF65-F5344CB8AC3E}">
-        <p14:creationId xmlns:p14="http://schemas.microsoft.com/office/powerpoint/2010/main" val="1024086991"/>
+        <p14:creationId xmlns:p14="http://schemas.microsoft.com/office/powerpoint/2010/main" val="366829449"/>
       </p:ext>
     </p:extLst>
   </p:cSld>
@@ -504,10 +299,6 @@
           <a:bodyPr/>
           <a:lstStyle/>
           <a:p>
-            <a:r>
-              <a:rPr lang="en-US" dirty="0"/>
-              <a:t/>
-            </a:r>
             <a:endParaRPr lang="en-US" dirty="0"/>
           </a:p>
         </p:txBody>
@@ -592,10 +383,6 @@
           <a:bodyPr/>
           <a:lstStyle/>
           <a:p>
-            <a:r>
-              <a:rPr lang="en-US" dirty="0"/>
-              <a:t/>
-            </a:r>
             <a:endParaRPr lang="en-US" dirty="0"/>
           </a:p>
         </p:txBody>
@@ -680,10 +467,6 @@
           <a:bodyPr/>
           <a:lstStyle/>
           <a:p>
-            <a:r>
-              <a:rPr lang="en-US" dirty="0"/>
-              <a:t/>
-            </a:r>
             <a:endParaRPr lang="en-US" dirty="0"/>
           </a:p>
         </p:txBody>
@@ -705,7 +488,7 @@
           <a:p>
             <a:fld id="{F7021451-1387-4CA6-816F-3879F97B5CBC}" type="slidenum">
               <a:rPr lang="en-US"/>
-              <a:t>3</a:t>
+              <a:t>4</a:t>
             </a:fld>
             <a:endParaRPr lang="en-US"/>
           </a:p>
@@ -768,10 +551,6 @@
           <a:bodyPr/>
           <a:lstStyle/>
           <a:p>
-            <a:r>
-              <a:rPr lang="en-US" dirty="0"/>
-              <a:t/>
-            </a:r>
             <a:endParaRPr lang="en-US" dirty="0"/>
           </a:p>
         </p:txBody>
@@ -793,7 +572,7 @@
           <a:p>
             <a:fld id="{F7021451-1387-4CA6-816F-3879F97B5CBC}" type="slidenum">
               <a:rPr lang="en-US"/>
-              <a:t>4</a:t>
+              <a:t>5</a:t>
             </a:fld>
             <a:endParaRPr lang="en-US"/>
           </a:p>
@@ -856,10 +635,6 @@
           <a:bodyPr/>
           <a:lstStyle/>
           <a:p>
-            <a:r>
-              <a:rPr lang="en-US" dirty="0"/>
-              <a:t/>
-            </a:r>
             <a:endParaRPr lang="en-US" dirty="0"/>
           </a:p>
         </p:txBody>
@@ -881,7 +656,7 @@
           <a:p>
             <a:fld id="{F7021451-1387-4CA6-816F-3879F97B5CBC}" type="slidenum">
               <a:rPr lang="en-US"/>
-              <a:t>5</a:t>
+              <a:t>6</a:t>
             </a:fld>
             <a:endParaRPr lang="en-US"/>
           </a:p>
@@ -933,6 +708,11 @@
 <file path=ppt/slideMasters/slideMaster1.xml><?xml version="1.0" encoding="utf-8"?>
 <p:sldMaster xmlns:a="http://schemas.openxmlformats.org/drawingml/2006/main" xmlns:r="http://schemas.openxmlformats.org/officeDocument/2006/relationships" xmlns:p="http://schemas.openxmlformats.org/presentationml/2006/main">
   <p:cSld>
+    <p:bg>
+      <p:bgRef idx="1001">
+        <a:schemeClr val="bg1"/>
+      </p:bgRef>
+    </p:bg>
     <p:spTree>
       <p:nvGrpSpPr>
         <p:cNvPr id="1" name=""/>
@@ -1215,6 +995,7 @@
         <a:solidFill>
           <a:srgbClr val="1E293B"/>
         </a:solidFill>
+        <a:effectLst/>
       </p:bgPr>
     </p:bg>
     <p:spTree>
@@ -1252,7 +1033,7 @@
           <a:bodyPr wrap="square" lIns="0" tIns="0" rIns="0" bIns="0" rtlCol="0" anchor="ctr"/>
           <a:lstStyle/>
           <a:p>
-            <a:pPr indent="0" marL="0">
+            <a:pPr marL="0" indent="0">
               <a:buNone/>
             </a:pPr>
             <a:r>
@@ -1264,7 +1045,7 @@
                 <a:ea typeface="Arial Black" pitchFamily="34" charset="-122"/>
                 <a:cs typeface="Arial Black" pitchFamily="34" charset="-120"/>
               </a:rPr>
-              <a:t>LUNCH BOT</a:t>
+              <a:t>@Lunch_bot (AI Hype Edition)</a:t>
             </a:r>
             <a:endParaRPr lang="en-US" sz="6000" dirty="0"/>
           </a:p>
@@ -1278,7 +1059,7 @@
         </p:nvSpPr>
         <p:spPr>
           <a:xfrm>
-            <a:off x="457200" y="2834640"/>
+            <a:off x="457200" y="3611880"/>
             <a:ext cx="5486400" cy="457200"/>
           </a:xfrm>
           <a:prstGeom prst="rect">
@@ -1291,7 +1072,7 @@
           <a:bodyPr wrap="square" rtlCol="0" anchor="ctr"/>
           <a:lstStyle/>
           <a:p>
-            <a:pPr indent="0" marL="0">
+            <a:pPr marL="0" indent="0">
               <a:buNone/>
             </a:pPr>
             <a:r>
@@ -1303,7 +1084,7 @@
                 <a:ea typeface="Arial" pitchFamily="34" charset="-122"/>
                 <a:cs typeface="Arial" pitchFamily="34" charset="-120"/>
               </a:rPr>
-              <a:t>Automating Team Coordination &amp; Boosting Morale</a:t>
+              <a:t>Now with Gemini 3.1 Flash-Lite Intelligence</a:t>
             </a:r>
             <a:endParaRPr lang="en-US" sz="2000" dirty="0"/>
           </a:p>
@@ -1311,14 +1092,14 @@
       </p:sp>
       <p:pic>
         <p:nvPicPr>
-          <p:cNvPr id="4" name="Image 0" descr="mascot.png">    </p:cNvPr>
+          <p:cNvPr id="4" name="Image 0" descr="mascot.png"/>
           <p:cNvPicPr>
             <a:picLocks noChangeAspect="1"/>
           </p:cNvPicPr>
           <p:nvPr/>
         </p:nvPicPr>
         <p:blipFill>
-          <a:blip r:embed="rId1"/>
+          <a:blip r:embed="rId3"/>
           <a:stretch>
             <a:fillRect/>
           </a:stretch>
@@ -1341,7 +1122,7 @@
         </p:nvSpPr>
         <p:spPr>
           <a:xfrm>
-            <a:off x="457200" y="3474720"/>
+            <a:off x="457200" y="3634377"/>
             <a:ext cx="1828800" cy="45720"/>
           </a:xfrm>
           <a:prstGeom prst="rect">
@@ -1352,6 +1133,13 @@
           </a:solidFill>
           <a:ln/>
         </p:spPr>
+        <p:txBody>
+          <a:bodyPr/>
+          <a:lstStyle/>
+          <a:p>
+            <a:endParaRPr lang="en-SG"/>
+          </a:p>
+        </p:txBody>
       </p:sp>
     </p:spTree>
   </p:cSld>
@@ -1369,6 +1157,7 @@
         <a:solidFill>
           <a:srgbClr val="F3F4F6"/>
         </a:solidFill>
+        <a:effectLst/>
       </p:bgPr>
     </p:bg>
     <p:spTree>
@@ -1426,7 +1215,7 @@
           <a:bodyPr wrap="square" rtlCol="0" anchor="ctr"/>
           <a:lstStyle/>
           <a:p>
-            <a:pPr indent="0" marL="0">
+            <a:pPr marL="0" indent="0">
               <a:buNone/>
             </a:pPr>
             <a:r>
@@ -1485,7 +1274,7 @@
           <a:bodyPr wrap="square" rtlCol="0" anchor="ctr"/>
           <a:lstStyle/>
           <a:p>
-            <a:pPr algn="ctr" indent="0" marL="0">
+            <a:pPr marL="0" indent="0" algn="ctr">
               <a:buNone/>
             </a:pPr>
             <a:r>
@@ -1494,7 +1283,7 @@
                   <a:srgbClr val="FFFFFF"/>
                 </a:solidFill>
               </a:rPr>
-              <a:t>11:00 AM</a:t>
+              <a:t>10:45 AM</a:t>
             </a:r>
             <a:endParaRPr lang="en-US" sz="1400" dirty="0"/>
           </a:p>
@@ -1521,7 +1310,7 @@
           <a:bodyPr wrap="square" rtlCol="0" anchor="ctr"/>
           <a:lstStyle/>
           <a:p>
-            <a:pPr indent="0" marL="0">
+            <a:pPr marL="0" indent="0">
               <a:buNone/>
             </a:pPr>
             <a:r>
@@ -1533,7 +1322,7 @@
                 <a:ea typeface="Arial Black" pitchFamily="34" charset="-122"/>
                 <a:cs typeface="Arial Black" pitchFamily="34" charset="-120"/>
               </a:rPr>
-              <a:t>Dynamic Poll Launch</a:t>
+              <a:t>AI Hype &amp; Poll Launch</a:t>
             </a:r>
             <a:endParaRPr lang="en-US" sz="2000" dirty="0"/>
           </a:p>
@@ -1560,7 +1349,7 @@
           <a:bodyPr wrap="square" rtlCol="0" anchor="ctr"/>
           <a:lstStyle/>
           <a:p>
-            <a:pPr indent="0" marL="0">
+            <a:pPr marL="0" indent="0">
               <a:buNone/>
             </a:pPr>
             <a:r>
@@ -1569,7 +1358,7 @@
                   <a:srgbClr val="64748B"/>
                 </a:solidFill>
               </a:rPr>
-              <a:t>Instantly prompts the team: 'Who's coming for lunch today?'</a:t>
+              <a:t>Gemini 3.1 builds excitement (10:45) followed by the lunch poll (11:00).</a:t>
             </a:r>
             <a:endParaRPr lang="en-US" sz="1400" dirty="0"/>
           </a:p>
@@ -1616,7 +1405,7 @@
           <a:bodyPr wrap="square" rtlCol="0" anchor="ctr"/>
           <a:lstStyle/>
           <a:p>
-            <a:pPr algn="ctr" indent="0" marL="0">
+            <a:pPr marL="0" indent="0" algn="ctr">
               <a:buNone/>
             </a:pPr>
             <a:r>
@@ -1652,7 +1441,7 @@
           <a:bodyPr wrap="square" rtlCol="0" anchor="ctr"/>
           <a:lstStyle/>
           <a:p>
-            <a:pPr indent="0" marL="0">
+            <a:pPr marL="0" indent="0">
               <a:buNone/>
             </a:pPr>
             <a:r>
@@ -1691,7 +1480,7 @@
           <a:bodyPr wrap="square" rtlCol="0" anchor="ctr"/>
           <a:lstStyle/>
           <a:p>
-            <a:pPr indent="0" marL="0">
+            <a:pPr marL="0" indent="0">
               <a:buNone/>
             </a:pPr>
             <a:r>
@@ -1747,7 +1536,7 @@
           <a:bodyPr wrap="square" rtlCol="0" anchor="ctr"/>
           <a:lstStyle/>
           <a:p>
-            <a:pPr algn="ctr" indent="0" marL="0">
+            <a:pPr marL="0" indent="0" algn="ctr">
               <a:buNone/>
             </a:pPr>
             <a:r>
@@ -1783,7 +1572,7 @@
           <a:bodyPr wrap="square" rtlCol="0" anchor="ctr"/>
           <a:lstStyle/>
           <a:p>
-            <a:pPr indent="0" marL="0">
+            <a:pPr marL="0" indent="0">
               <a:buNone/>
             </a:pPr>
             <a:r>
@@ -1822,7 +1611,7 @@
           <a:bodyPr wrap="square" rtlCol="0" anchor="ctr"/>
           <a:lstStyle/>
           <a:p>
-            <a:pPr indent="0" marL="0">
+            <a:pPr marL="0" indent="0">
               <a:buNone/>
             </a:pPr>
             <a:r>
@@ -1853,6 +1642,7 @@
         <a:solidFill>
           <a:srgbClr val="F3F4F6"/>
         </a:solidFill>
+        <a:effectLst/>
       </p:bgPr>
     </p:bg>
     <p:spTree>
@@ -1910,7 +1700,7 @@
           <a:bodyPr wrap="square" rtlCol="0" anchor="ctr"/>
           <a:lstStyle/>
           <a:p>
-            <a:pPr indent="0" marL="0">
+            <a:pPr marL="0" indent="0">
               <a:buNone/>
             </a:pPr>
             <a:r>
@@ -1922,7 +1712,7 @@
                 <a:ea typeface="Arial Black" pitchFamily="34" charset="-122"/>
                 <a:cs typeface="Arial Black" pitchFamily="34" charset="-120"/>
               </a:rPr>
-              <a:t>Next-Gen Weather Intelligence</a:t>
+              <a:t>The AI Hype-Bot Persona</a:t>
             </a:r>
             <a:endParaRPr lang="en-US" sz="3600" dirty="0"/>
           </a:p>
@@ -1949,7 +1739,7 @@
           <a:bodyPr wrap="square" rtlCol="0" anchor="ctr"/>
           <a:lstStyle/>
           <a:p>
-            <a:pPr indent="0" marL="0">
+            <a:pPr marL="0" indent="0">
               <a:buNone/>
             </a:pPr>
             <a:r>
@@ -1958,7 +1748,7 @@
                   <a:srgbClr val="64748B"/>
                 </a:solidFill>
               </a:rPr>
-              <a:t>Real-time integration with data.gov.sg APIs optimized for the Kallang regional context.</a:t>
+              <a:t>Gemini 3.1 Flash-Lite: High Energy, Low Latency</a:t>
             </a:r>
             <a:endParaRPr lang="en-US" sz="1600" dirty="0"/>
           </a:p>
@@ -1983,7 +1773,7 @@
           </a:solidFill>
           <a:ln/>
           <a:effectLst>
-            <a:outerShdw sx="100000" sy="100000" kx="0" ky="0" algn="bl" rotWithShape="0" blurRad="127000" dist="50800" dir="16200000">
+            <a:outerShdw blurRad="127000" dist="50800" dir="16200000" algn="bl" rotWithShape="0">
               <a:srgbClr val="000000">
                 <a:alpha val="10000"/>
               </a:srgbClr>
@@ -2012,7 +1802,7 @@
           <a:bodyPr wrap="square" rtlCol="0" anchor="ctr"/>
           <a:lstStyle/>
           <a:p>
-            <a:pPr algn="ctr" indent="0" marL="0">
+            <a:pPr marL="0" indent="0" algn="ctr">
               <a:buNone/>
             </a:pPr>
             <a:r>
@@ -2021,7 +1811,7 @@
                   <a:srgbClr val="000000"/>
                 </a:solidFill>
               </a:rPr>
-              <a:t>⛈️</a:t>
+              <a:t>🔥</a:t>
             </a:r>
             <a:endParaRPr lang="en-US" sz="4000" dirty="0"/>
           </a:p>
@@ -2048,7 +1838,7 @@
           <a:bodyPr wrap="square" rtlCol="0" anchor="ctr"/>
           <a:lstStyle/>
           <a:p>
-            <a:pPr algn="ctr" indent="0" marL="0">
+            <a:pPr marL="0" indent="0" algn="ctr">
               <a:buNone/>
             </a:pPr>
             <a:r>
@@ -2060,7 +1850,7 @@
                 <a:ea typeface="Arial Black" pitchFamily="34" charset="-122"/>
                 <a:cs typeface="Arial Black" pitchFamily="34" charset="-120"/>
               </a:rPr>
-              <a:t>RAIN ALERT</a:t>
+              <a:t>PERSONALITY</a:t>
             </a:r>
             <a:endParaRPr lang="en-US" sz="1600" dirty="0"/>
           </a:p>
@@ -2087,7 +1877,7 @@
           <a:bodyPr wrap="square" rtlCol="0" anchor="ctr"/>
           <a:lstStyle/>
           <a:p>
-            <a:pPr algn="ctr" indent="0" marL="0">
+            <a:pPr marL="0" indent="0" algn="ctr">
               <a:buNone/>
             </a:pPr>
             <a:r>
@@ -2096,7 +1886,7 @@
                   <a:srgbClr val="64748B"/>
                 </a:solidFill>
               </a:rPr>
-              <a:t>Detects 'Rain', 'Showers', or 'Storm' in 2h forecast.</a:t>
+              <a:t>High energy, enthusiastic, and food-obsessed.</a:t>
             </a:r>
             <a:endParaRPr lang="en-US" sz="1400" dirty="0"/>
           </a:p>
@@ -2121,7 +1911,7 @@
           </a:solidFill>
           <a:ln/>
           <a:effectLst>
-            <a:outerShdw sx="100000" sy="100000" kx="0" ky="0" algn="bl" rotWithShape="0" blurRad="127000" dist="50800" dir="16200000">
+            <a:outerShdw blurRad="127000" dist="50800" dir="16200000" algn="bl" rotWithShape="0">
               <a:srgbClr val="000000">
                 <a:alpha val="10000"/>
               </a:srgbClr>
@@ -2150,7 +1940,7 @@
           <a:bodyPr wrap="square" rtlCol="0" anchor="ctr"/>
           <a:lstStyle/>
           <a:p>
-            <a:pPr algn="ctr" indent="0" marL="0">
+            <a:pPr marL="0" indent="0" algn="ctr">
               <a:buNone/>
             </a:pPr>
             <a:r>
@@ -2159,7 +1949,7 @@
                   <a:srgbClr val="000000"/>
                 </a:solidFill>
               </a:rPr>
-              <a:t>🧴</a:t>
+              <a:t>🇸🇬</a:t>
             </a:r>
             <a:endParaRPr lang="en-US" sz="4000" dirty="0"/>
           </a:p>
@@ -2186,7 +1976,7 @@
           <a:bodyPr wrap="square" rtlCol="0" anchor="ctr"/>
           <a:lstStyle/>
           <a:p>
-            <a:pPr algn="ctr" indent="0" marL="0">
+            <a:pPr marL="0" indent="0" algn="ctr">
               <a:buNone/>
             </a:pPr>
             <a:r>
@@ -2198,7 +1988,7 @@
                 <a:ea typeface="Arial Black" pitchFamily="34" charset="-122"/>
                 <a:cs typeface="Arial Black" pitchFamily="34" charset="-120"/>
               </a:rPr>
-              <a:t>UV PROTECTION</a:t>
+              <a:t>CULTURE</a:t>
             </a:r>
             <a:endParaRPr lang="en-US" sz="1600" dirty="0"/>
           </a:p>
@@ -2225,7 +2015,7 @@
           <a:bodyPr wrap="square" rtlCol="0" anchor="ctr"/>
           <a:lstStyle/>
           <a:p>
-            <a:pPr algn="ctr" indent="0" marL="0">
+            <a:pPr marL="0" indent="0" algn="ctr">
               <a:buNone/>
             </a:pPr>
             <a:r>
@@ -2234,7 +2024,7 @@
                   <a:srgbClr val="64748B"/>
                 </a:solidFill>
               </a:rPr>
-              <a:t>Warns if UV Index exceeds level 6 (High to Extreme).</a:t>
+              <a:t>SGT localized responses (Chicken Rice, Hawker Dash).</a:t>
             </a:r>
             <a:endParaRPr lang="en-US" sz="1400" dirty="0"/>
           </a:p>
@@ -2259,7 +2049,7 @@
           </a:solidFill>
           <a:ln/>
           <a:effectLst>
-            <a:outerShdw sx="100000" sy="100000" kx="0" ky="0" algn="bl" rotWithShape="0" blurRad="127000" dist="50800" dir="16200000">
+            <a:outerShdw blurRad="127000" dist="50800" dir="16200000" algn="bl" rotWithShape="0">
               <a:srgbClr val="000000">
                 <a:alpha val="10000"/>
               </a:srgbClr>
@@ -2288,7 +2078,7 @@
           <a:bodyPr wrap="square" rtlCol="0" anchor="ctr"/>
           <a:lstStyle/>
           <a:p>
-            <a:pPr algn="ctr" indent="0" marL="0">
+            <a:pPr marL="0" indent="0" algn="ctr">
               <a:buNone/>
             </a:pPr>
             <a:r>
@@ -2297,7 +2087,7 @@
                   <a:srgbClr val="000000"/>
                 </a:solidFill>
               </a:rPr>
-              <a:t>🌡️</a:t>
+              <a:t>🧠</a:t>
             </a:r>
             <a:endParaRPr lang="en-US" sz="4000" dirty="0"/>
           </a:p>
@@ -2324,7 +2114,7 @@
           <a:bodyPr wrap="square" rtlCol="0" anchor="ctr"/>
           <a:lstStyle/>
           <a:p>
-            <a:pPr algn="ctr" indent="0" marL="0">
+            <a:pPr marL="0" indent="0" algn="ctr">
               <a:buNone/>
             </a:pPr>
             <a:r>
@@ -2336,7 +2126,7 @@
                 <a:ea typeface="Arial Black" pitchFamily="34" charset="-122"/>
                 <a:cs typeface="Arial Black" pitchFamily="34" charset="-120"/>
               </a:rPr>
-              <a:t>HEAT INDEX</a:t>
+              <a:t>INTELLIGENCE</a:t>
             </a:r>
             <a:endParaRPr lang="en-US" sz="1600" dirty="0"/>
           </a:p>
@@ -2363,7 +2153,7 @@
           <a:bodyPr wrap="square" rtlCol="0" anchor="ctr"/>
           <a:lstStyle/>
           <a:p>
-            <a:pPr algn="ctr" indent="0" marL="0">
+            <a:pPr marL="0" indent="0" algn="ctr">
               <a:buNone/>
             </a:pPr>
             <a:r>
@@ -2372,7 +2162,7 @@
                   <a:srgbClr val="64748B"/>
                 </a:solidFill>
               </a:rPr>
-              <a:t>Triggers if 'Feels Like' temperature exceeds 33°C.</a:t>
+              <a:t>Analyzes weather &amp; participation for context-aware hype.</a:t>
             </a:r>
             <a:endParaRPr lang="en-US" sz="1400" dirty="0"/>
           </a:p>
@@ -2388,12 +2178,13 @@
 
 <file path=ppt/slides/slide4.xml><?xml version="1.0" encoding="utf-8"?>
 <p:sld xmlns:a="http://schemas.openxmlformats.org/drawingml/2006/main" xmlns:r="http://schemas.openxmlformats.org/officeDocument/2006/relationships" xmlns:p="http://schemas.openxmlformats.org/presentationml/2006/main">
-  <p:cSld name="Slide 4">
+  <p:cSld name="Slide 3">
     <p:bg>
       <p:bgPr>
         <a:solidFill>
           <a:srgbClr val="F3F4F6"/>
         </a:solidFill>
+        <a:effectLst/>
       </p:bgPr>
     </p:bg>
     <p:spTree>
@@ -2451,7 +2242,549 @@
           <a:bodyPr wrap="square" rtlCol="0" anchor="ctr"/>
           <a:lstStyle/>
           <a:p>
-            <a:pPr indent="0" marL="0">
+            <a:pPr marL="0" indent="0">
+              <a:buNone/>
+            </a:pPr>
+            <a:r>
+              <a:rPr lang="en-US" sz="3600" dirty="0">
+                <a:solidFill>
+                  <a:srgbClr val="1E293B"/>
+                </a:solidFill>
+                <a:latin typeface="Arial Black" pitchFamily="34" charset="0"/>
+                <a:ea typeface="Arial Black" pitchFamily="34" charset="-122"/>
+                <a:cs typeface="Arial Black" pitchFamily="34" charset="-120"/>
+              </a:rPr>
+              <a:t>Next-Gen Weather Intelligence</a:t>
+            </a:r>
+            <a:endParaRPr lang="en-US" sz="3600" dirty="0"/>
+          </a:p>
+        </p:txBody>
+      </p:sp>
+      <p:sp>
+        <p:nvSpPr>
+          <p:cNvPr id="4" name="Text 2"/>
+          <p:cNvSpPr/>
+          <p:nvPr/>
+        </p:nvSpPr>
+        <p:spPr>
+          <a:xfrm>
+            <a:off x="457200" y="1005840"/>
+            <a:ext cx="7315200" cy="457200"/>
+          </a:xfrm>
+          <a:prstGeom prst="rect">
+            <a:avLst/>
+          </a:prstGeom>
+          <a:noFill/>
+          <a:ln/>
+        </p:spPr>
+        <p:txBody>
+          <a:bodyPr wrap="square" rtlCol="0" anchor="ctr"/>
+          <a:lstStyle/>
+          <a:p>
+            <a:pPr marL="0" indent="0">
+              <a:buNone/>
+            </a:pPr>
+            <a:r>
+              <a:rPr lang="en-US" sz="1600" dirty="0">
+                <a:solidFill>
+                  <a:srgbClr val="64748B"/>
+                </a:solidFill>
+              </a:rPr>
+              <a:t>Real-time AI analysis of data.gov.sg APIs optimized for the Kallang regional context.</a:t>
+            </a:r>
+            <a:endParaRPr lang="en-US" sz="1600" dirty="0"/>
+          </a:p>
+        </p:txBody>
+      </p:sp>
+      <p:sp>
+        <p:nvSpPr>
+          <p:cNvPr id="5" name="Shape 3"/>
+          <p:cNvSpPr/>
+          <p:nvPr/>
+        </p:nvSpPr>
+        <p:spPr>
+          <a:xfrm>
+            <a:off x="457200" y="1828800"/>
+            <a:ext cx="2560320" cy="2743200"/>
+          </a:xfrm>
+          <a:prstGeom prst="rect">
+            <a:avLst/>
+          </a:prstGeom>
+          <a:solidFill>
+            <a:srgbClr val="FFFFFF"/>
+          </a:solidFill>
+          <a:ln/>
+          <a:effectLst>
+            <a:outerShdw blurRad="127000" dist="50800" dir="16200000" algn="bl" rotWithShape="0">
+              <a:srgbClr val="000000">
+                <a:alpha val="10000"/>
+              </a:srgbClr>
+            </a:outerShdw>
+          </a:effectLst>
+        </p:spPr>
+      </p:sp>
+      <p:sp>
+        <p:nvSpPr>
+          <p:cNvPr id="6" name="Text 4"/>
+          <p:cNvSpPr/>
+          <p:nvPr/>
+        </p:nvSpPr>
+        <p:spPr>
+          <a:xfrm>
+            <a:off x="457200" y="2011680"/>
+            <a:ext cx="2560320" cy="731520"/>
+          </a:xfrm>
+          <a:prstGeom prst="rect">
+            <a:avLst/>
+          </a:prstGeom>
+          <a:noFill/>
+          <a:ln/>
+        </p:spPr>
+        <p:txBody>
+          <a:bodyPr wrap="square" rtlCol="0" anchor="ctr"/>
+          <a:lstStyle/>
+          <a:p>
+            <a:pPr marL="0" indent="0" algn="ctr">
+              <a:buNone/>
+            </a:pPr>
+            <a:r>
+              <a:rPr lang="en-US" sz="4000" dirty="0">
+                <a:solidFill>
+                  <a:srgbClr val="000000"/>
+                </a:solidFill>
+              </a:rPr>
+              <a:t>⛈️</a:t>
+            </a:r>
+            <a:endParaRPr lang="en-US" sz="4000" dirty="0"/>
+          </a:p>
+        </p:txBody>
+      </p:sp>
+      <p:sp>
+        <p:nvSpPr>
+          <p:cNvPr id="7" name="Text 5"/>
+          <p:cNvSpPr/>
+          <p:nvPr/>
+        </p:nvSpPr>
+        <p:spPr>
+          <a:xfrm>
+            <a:off x="457200" y="2743200"/>
+            <a:ext cx="2560320" cy="365760"/>
+          </a:xfrm>
+          <a:prstGeom prst="rect">
+            <a:avLst/>
+          </a:prstGeom>
+          <a:noFill/>
+          <a:ln/>
+        </p:spPr>
+        <p:txBody>
+          <a:bodyPr wrap="square" rtlCol="0" anchor="ctr"/>
+          <a:lstStyle/>
+          <a:p>
+            <a:pPr marL="0" indent="0" algn="ctr">
+              <a:buNone/>
+            </a:pPr>
+            <a:r>
+              <a:rPr lang="en-US" sz="1600" dirty="0">
+                <a:solidFill>
+                  <a:srgbClr val="028090"/>
+                </a:solidFill>
+                <a:latin typeface="Arial Black" pitchFamily="34" charset="0"/>
+                <a:ea typeface="Arial Black" pitchFamily="34" charset="-122"/>
+                <a:cs typeface="Arial Black" pitchFamily="34" charset="-120"/>
+              </a:rPr>
+              <a:t>RAIN ALERT</a:t>
+            </a:r>
+            <a:endParaRPr lang="en-US" sz="1600" dirty="0"/>
+          </a:p>
+        </p:txBody>
+      </p:sp>
+      <p:sp>
+        <p:nvSpPr>
+          <p:cNvPr id="8" name="Text 6"/>
+          <p:cNvSpPr/>
+          <p:nvPr/>
+        </p:nvSpPr>
+        <p:spPr>
+          <a:xfrm>
+            <a:off x="640080" y="3200400"/>
+            <a:ext cx="2194560" cy="1097280"/>
+          </a:xfrm>
+          <a:prstGeom prst="rect">
+            <a:avLst/>
+          </a:prstGeom>
+          <a:noFill/>
+          <a:ln/>
+        </p:spPr>
+        <p:txBody>
+          <a:bodyPr wrap="square" rtlCol="0" anchor="ctr"/>
+          <a:lstStyle/>
+          <a:p>
+            <a:pPr marL="0" indent="0" algn="ctr">
+              <a:buNone/>
+            </a:pPr>
+            <a:r>
+              <a:rPr lang="en-US" sz="1400" dirty="0">
+                <a:solidFill>
+                  <a:srgbClr val="64748B"/>
+                </a:solidFill>
+              </a:rPr>
+              <a:t>Detects 'Rain', 'Showers', or 'Storm' in 2h forecast.</a:t>
+            </a:r>
+            <a:endParaRPr lang="en-US" sz="1400" dirty="0"/>
+          </a:p>
+        </p:txBody>
+      </p:sp>
+      <p:sp>
+        <p:nvSpPr>
+          <p:cNvPr id="9" name="Shape 7"/>
+          <p:cNvSpPr/>
+          <p:nvPr/>
+        </p:nvSpPr>
+        <p:spPr>
+          <a:xfrm>
+            <a:off x="3291840" y="1828800"/>
+            <a:ext cx="2560320" cy="2743200"/>
+          </a:xfrm>
+          <a:prstGeom prst="rect">
+            <a:avLst/>
+          </a:prstGeom>
+          <a:solidFill>
+            <a:srgbClr val="FFFFFF"/>
+          </a:solidFill>
+          <a:ln/>
+          <a:effectLst>
+            <a:outerShdw blurRad="127000" dist="50800" dir="16200000" algn="bl" rotWithShape="0">
+              <a:srgbClr val="000000">
+                <a:alpha val="10000"/>
+              </a:srgbClr>
+            </a:outerShdw>
+          </a:effectLst>
+        </p:spPr>
+      </p:sp>
+      <p:sp>
+        <p:nvSpPr>
+          <p:cNvPr id="10" name="Text 8"/>
+          <p:cNvSpPr/>
+          <p:nvPr/>
+        </p:nvSpPr>
+        <p:spPr>
+          <a:xfrm>
+            <a:off x="3291840" y="2011680"/>
+            <a:ext cx="2560320" cy="731520"/>
+          </a:xfrm>
+          <a:prstGeom prst="rect">
+            <a:avLst/>
+          </a:prstGeom>
+          <a:noFill/>
+          <a:ln/>
+        </p:spPr>
+        <p:txBody>
+          <a:bodyPr wrap="square" rtlCol="0" anchor="ctr"/>
+          <a:lstStyle/>
+          <a:p>
+            <a:pPr marL="0" indent="0" algn="ctr">
+              <a:buNone/>
+            </a:pPr>
+            <a:r>
+              <a:rPr lang="en-US" sz="4000" dirty="0">
+                <a:solidFill>
+                  <a:srgbClr val="000000"/>
+                </a:solidFill>
+              </a:rPr>
+              <a:t>🧴</a:t>
+            </a:r>
+            <a:endParaRPr lang="en-US" sz="4000" dirty="0"/>
+          </a:p>
+        </p:txBody>
+      </p:sp>
+      <p:sp>
+        <p:nvSpPr>
+          <p:cNvPr id="11" name="Text 9"/>
+          <p:cNvSpPr/>
+          <p:nvPr/>
+        </p:nvSpPr>
+        <p:spPr>
+          <a:xfrm>
+            <a:off x="3291840" y="2743200"/>
+            <a:ext cx="2560320" cy="365760"/>
+          </a:xfrm>
+          <a:prstGeom prst="rect">
+            <a:avLst/>
+          </a:prstGeom>
+          <a:noFill/>
+          <a:ln/>
+        </p:spPr>
+        <p:txBody>
+          <a:bodyPr wrap="square" rtlCol="0" anchor="ctr"/>
+          <a:lstStyle/>
+          <a:p>
+            <a:pPr marL="0" indent="0" algn="ctr">
+              <a:buNone/>
+            </a:pPr>
+            <a:r>
+              <a:rPr lang="en-US" sz="1600" dirty="0">
+                <a:solidFill>
+                  <a:srgbClr val="028090"/>
+                </a:solidFill>
+                <a:latin typeface="Arial Black" pitchFamily="34" charset="0"/>
+                <a:ea typeface="Arial Black" pitchFamily="34" charset="-122"/>
+                <a:cs typeface="Arial Black" pitchFamily="34" charset="-120"/>
+              </a:rPr>
+              <a:t>UV PROTECTION</a:t>
+            </a:r>
+            <a:endParaRPr lang="en-US" sz="1600" dirty="0"/>
+          </a:p>
+        </p:txBody>
+      </p:sp>
+      <p:sp>
+        <p:nvSpPr>
+          <p:cNvPr id="12" name="Text 10"/>
+          <p:cNvSpPr/>
+          <p:nvPr/>
+        </p:nvSpPr>
+        <p:spPr>
+          <a:xfrm>
+            <a:off x="3474720" y="3200400"/>
+            <a:ext cx="2194560" cy="1097280"/>
+          </a:xfrm>
+          <a:prstGeom prst="rect">
+            <a:avLst/>
+          </a:prstGeom>
+          <a:noFill/>
+          <a:ln/>
+        </p:spPr>
+        <p:txBody>
+          <a:bodyPr wrap="square" rtlCol="0" anchor="ctr"/>
+          <a:lstStyle/>
+          <a:p>
+            <a:pPr marL="0" indent="0" algn="ctr">
+              <a:buNone/>
+            </a:pPr>
+            <a:r>
+              <a:rPr lang="en-US" sz="1400" dirty="0">
+                <a:solidFill>
+                  <a:srgbClr val="64748B"/>
+                </a:solidFill>
+              </a:rPr>
+              <a:t>Warns if UV Index exceeds level 6 (High to Extreme).</a:t>
+            </a:r>
+            <a:endParaRPr lang="en-US" sz="1400" dirty="0"/>
+          </a:p>
+        </p:txBody>
+      </p:sp>
+      <p:sp>
+        <p:nvSpPr>
+          <p:cNvPr id="13" name="Shape 11"/>
+          <p:cNvSpPr/>
+          <p:nvPr/>
+        </p:nvSpPr>
+        <p:spPr>
+          <a:xfrm>
+            <a:off x="6126480" y="1828800"/>
+            <a:ext cx="2560320" cy="2743200"/>
+          </a:xfrm>
+          <a:prstGeom prst="rect">
+            <a:avLst/>
+          </a:prstGeom>
+          <a:solidFill>
+            <a:srgbClr val="FFFFFF"/>
+          </a:solidFill>
+          <a:ln/>
+          <a:effectLst>
+            <a:outerShdw blurRad="127000" dist="50800" dir="16200000" algn="bl" rotWithShape="0">
+              <a:srgbClr val="000000">
+                <a:alpha val="10000"/>
+              </a:srgbClr>
+            </a:outerShdw>
+          </a:effectLst>
+        </p:spPr>
+      </p:sp>
+      <p:sp>
+        <p:nvSpPr>
+          <p:cNvPr id="14" name="Text 12"/>
+          <p:cNvSpPr/>
+          <p:nvPr/>
+        </p:nvSpPr>
+        <p:spPr>
+          <a:xfrm>
+            <a:off x="6126480" y="2011680"/>
+            <a:ext cx="2560320" cy="731520"/>
+          </a:xfrm>
+          <a:prstGeom prst="rect">
+            <a:avLst/>
+          </a:prstGeom>
+          <a:noFill/>
+          <a:ln/>
+        </p:spPr>
+        <p:txBody>
+          <a:bodyPr wrap="square" rtlCol="0" anchor="ctr"/>
+          <a:lstStyle/>
+          <a:p>
+            <a:pPr marL="0" indent="0" algn="ctr">
+              <a:buNone/>
+            </a:pPr>
+            <a:r>
+              <a:rPr lang="en-US" sz="4000" dirty="0">
+                <a:solidFill>
+                  <a:srgbClr val="000000"/>
+                </a:solidFill>
+              </a:rPr>
+              <a:t>🌡️</a:t>
+            </a:r>
+            <a:endParaRPr lang="en-US" sz="4000" dirty="0"/>
+          </a:p>
+        </p:txBody>
+      </p:sp>
+      <p:sp>
+        <p:nvSpPr>
+          <p:cNvPr id="15" name="Text 13"/>
+          <p:cNvSpPr/>
+          <p:nvPr/>
+        </p:nvSpPr>
+        <p:spPr>
+          <a:xfrm>
+            <a:off x="6126480" y="2743200"/>
+            <a:ext cx="2560320" cy="365760"/>
+          </a:xfrm>
+          <a:prstGeom prst="rect">
+            <a:avLst/>
+          </a:prstGeom>
+          <a:noFill/>
+          <a:ln/>
+        </p:spPr>
+        <p:txBody>
+          <a:bodyPr wrap="square" rtlCol="0" anchor="ctr"/>
+          <a:lstStyle/>
+          <a:p>
+            <a:pPr marL="0" indent="0" algn="ctr">
+              <a:buNone/>
+            </a:pPr>
+            <a:r>
+              <a:rPr lang="en-US" sz="1600" dirty="0">
+                <a:solidFill>
+                  <a:srgbClr val="028090"/>
+                </a:solidFill>
+                <a:latin typeface="Arial Black" pitchFamily="34" charset="0"/>
+                <a:ea typeface="Arial Black" pitchFamily="34" charset="-122"/>
+                <a:cs typeface="Arial Black" pitchFamily="34" charset="-120"/>
+              </a:rPr>
+              <a:t>HEAT INDEX</a:t>
+            </a:r>
+            <a:endParaRPr lang="en-US" sz="1600" dirty="0"/>
+          </a:p>
+        </p:txBody>
+      </p:sp>
+      <p:sp>
+        <p:nvSpPr>
+          <p:cNvPr id="16" name="Text 14"/>
+          <p:cNvSpPr/>
+          <p:nvPr/>
+        </p:nvSpPr>
+        <p:spPr>
+          <a:xfrm>
+            <a:off x="6309360" y="3200400"/>
+            <a:ext cx="2194560" cy="1097280"/>
+          </a:xfrm>
+          <a:prstGeom prst="rect">
+            <a:avLst/>
+          </a:prstGeom>
+          <a:noFill/>
+          <a:ln/>
+        </p:spPr>
+        <p:txBody>
+          <a:bodyPr wrap="square" rtlCol="0" anchor="ctr"/>
+          <a:lstStyle/>
+          <a:p>
+            <a:pPr marL="0" indent="0" algn="ctr">
+              <a:buNone/>
+            </a:pPr>
+            <a:r>
+              <a:rPr lang="en-US" sz="1400" dirty="0">
+                <a:solidFill>
+                  <a:srgbClr val="64748B"/>
+                </a:solidFill>
+              </a:rPr>
+              <a:t>Triggers if 'Feels Like' temperature exceeds 33°C.</a:t>
+            </a:r>
+            <a:endParaRPr lang="en-US" sz="1400" dirty="0"/>
+          </a:p>
+        </p:txBody>
+      </p:sp>
+    </p:spTree>
+  </p:cSld>
+  <p:clrMapOvr>
+    <a:masterClrMapping/>
+  </p:clrMapOvr>
+</p:sld>
+</file>
+
+<file path=ppt/slides/slide5.xml><?xml version="1.0" encoding="utf-8"?>
+<p:sld xmlns:a="http://schemas.openxmlformats.org/drawingml/2006/main" xmlns:r="http://schemas.openxmlformats.org/officeDocument/2006/relationships" xmlns:p="http://schemas.openxmlformats.org/presentationml/2006/main">
+  <p:cSld name="Slide 4">
+    <p:bg>
+      <p:bgPr>
+        <a:solidFill>
+          <a:srgbClr val="F3F4F6"/>
+        </a:solidFill>
+        <a:effectLst/>
+      </p:bgPr>
+    </p:bg>
+    <p:spTree>
+      <p:nvGrpSpPr>
+        <p:cNvPr id="1" name=""/>
+        <p:cNvGrpSpPr/>
+        <p:nvPr/>
+      </p:nvGrpSpPr>
+      <p:grpSpPr>
+        <a:xfrm>
+          <a:off x="0" y="0"/>
+          <a:ext cx="0" cy="0"/>
+          <a:chOff x="0" y="0"/>
+          <a:chExt cx="0" cy="0"/>
+        </a:xfrm>
+      </p:grpSpPr>
+      <p:sp>
+        <p:nvSpPr>
+          <p:cNvPr id="2" name="Shape 0"/>
+          <p:cNvSpPr/>
+          <p:nvPr/>
+        </p:nvSpPr>
+        <p:spPr>
+          <a:xfrm>
+            <a:off x="0" y="0"/>
+            <a:ext cx="91440" cy="5143500"/>
+          </a:xfrm>
+          <a:prstGeom prst="rect">
+            <a:avLst/>
+          </a:prstGeom>
+          <a:solidFill>
+            <a:srgbClr val="028090"/>
+          </a:solidFill>
+          <a:ln/>
+        </p:spPr>
+      </p:sp>
+      <p:sp>
+        <p:nvSpPr>
+          <p:cNvPr id="3" name="Text 1"/>
+          <p:cNvSpPr/>
+          <p:nvPr/>
+        </p:nvSpPr>
+        <p:spPr>
+          <a:xfrm>
+            <a:off x="457200" y="274320"/>
+            <a:ext cx="8229600" cy="731520"/>
+          </a:xfrm>
+          <a:prstGeom prst="rect">
+            <a:avLst/>
+          </a:prstGeom>
+          <a:noFill/>
+          <a:ln/>
+        </p:spPr>
+        <p:txBody>
+          <a:bodyPr wrap="square" rtlCol="0" anchor="ctr"/>
+          <a:lstStyle/>
+          <a:p>
+            <a:pPr marL="0" indent="0">
               <a:buNone/>
             </a:pPr>
             <a:r>
@@ -2490,7 +2823,7 @@
           <a:bodyPr wrap="square" rtlCol="0" anchor="ctr"/>
           <a:lstStyle/>
           <a:p>
-            <a:pPr indent="0" marL="0">
+            <a:pPr marL="0" indent="0">
               <a:buNone/>
             </a:pPr>
             <a:r>
@@ -2528,9 +2861,27 @@
             <a:tbl>
               <a:tblPr/>
               <a:tblGrid>
-                <a:gridCol w="2743200"/>
-                <a:gridCol w="2743200"/>
-                <a:gridCol w="2743200"/>
+                <a:gridCol w="2743200">
+                  <a:extLst>
+                    <a:ext uri="{9D8B030D-6E8A-4147-A177-3AD203B41FA5}">
+                      <a16:colId xmlns:a16="http://schemas.microsoft.com/office/drawing/2014/main" val="20000"/>
+                    </a:ext>
+                  </a:extLst>
+                </a:gridCol>
+                <a:gridCol w="2743200">
+                  <a:extLst>
+                    <a:ext uri="{9D8B030D-6E8A-4147-A177-3AD203B41FA5}">
+                      <a16:colId xmlns:a16="http://schemas.microsoft.com/office/drawing/2014/main" val="20001"/>
+                    </a:ext>
+                  </a:extLst>
+                </a:gridCol>
+                <a:gridCol w="2743200">
+                  <a:extLst>
+                    <a:ext uri="{9D8B030D-6E8A-4147-A177-3AD203B41FA5}">
+                      <a16:colId xmlns:a16="http://schemas.microsoft.com/office/drawing/2014/main" val="20002"/>
+                    </a:ext>
+                  </a:extLst>
+                </a:gridCol>
               </a:tblGrid>
               <a:tr h="571500">
                 <a:tc>
@@ -2538,7 +2889,7 @@
                     <a:bodyPr/>
                     <a:lstStyle/>
                     <a:p>
-                      <a:pPr algn="ctr" indent="0" marL="0">
+                      <a:pPr marL="0" indent="0" algn="ctr">
                         <a:buNone/>
                       </a:pPr>
                       <a:r>
@@ -2552,7 +2903,7 @@
                       <a:endParaRPr lang="en-US" sz="1400" dirty="0"/>
                     </a:p>
                   </a:txBody>
-                  <a:tcPr marL="91440" marR="91440" marT="45720" marB="45720" anchor="ctr">
+                  <a:tcPr anchor="ctr">
                     <a:lnL w="12700" cap="flat" cmpd="sng" algn="ctr">
                       <a:solidFill>
                         <a:srgbClr val="E2E8F0"/>
@@ -2599,7 +2950,7 @@
                     <a:bodyPr/>
                     <a:lstStyle/>
                     <a:p>
-                      <a:pPr algn="ctr" indent="0" marL="0">
+                      <a:pPr marL="0" indent="0" algn="ctr">
                         <a:buNone/>
                       </a:pPr>
                       <a:r>
@@ -2613,7 +2964,7 @@
                       <a:endParaRPr lang="en-US" sz="1400" dirty="0"/>
                     </a:p>
                   </a:txBody>
-                  <a:tcPr marL="91440" marR="91440" marT="45720" marB="45720" anchor="ctr">
+                  <a:tcPr anchor="ctr">
                     <a:lnL w="12700" cap="flat" cmpd="sng" algn="ctr">
                       <a:solidFill>
                         <a:srgbClr val="E2E8F0"/>
@@ -2660,7 +3011,7 @@
                     <a:bodyPr/>
                     <a:lstStyle/>
                     <a:p>
-                      <a:pPr algn="ctr" indent="0" marL="0">
+                      <a:pPr marL="0" indent="0" algn="ctr">
                         <a:buNone/>
                       </a:pPr>
                       <a:r>
@@ -2674,7 +3025,7 @@
                       <a:endParaRPr lang="en-US" sz="1400" dirty="0"/>
                     </a:p>
                   </a:txBody>
-                  <a:tcPr marL="91440" marR="91440" marT="45720" marB="45720" anchor="ctr">
+                  <a:tcPr anchor="ctr">
                     <a:lnL w="12700" cap="flat" cmpd="sng" algn="ctr">
                       <a:solidFill>
                         <a:srgbClr val="E2E8F0"/>
@@ -2716,6 +3067,11 @@
                     </a:solidFill>
                   </a:tcPr>
                 </a:tc>
+                <a:extLst>
+                  <a:ext uri="{0D108BD9-81ED-4DB2-BD59-A6C34878D82A}">
+                    <a16:rowId xmlns:a16="http://schemas.microsoft.com/office/drawing/2014/main" val="10000"/>
+                  </a:ext>
+                </a:extLst>
               </a:tr>
               <a:tr h="571500">
                 <a:tc>
@@ -2723,7 +3079,7 @@
                     <a:bodyPr/>
                     <a:lstStyle/>
                     <a:p>
-                      <a:pPr algn="ctr" indent="0" marL="0">
+                      <a:pPr marL="0" indent="0" algn="ctr">
                         <a:buNone/>
                       </a:pPr>
                       <a:r>
@@ -2737,7 +3093,7 @@
                       <a:endParaRPr lang="en-US" sz="1400" dirty="0"/>
                     </a:p>
                   </a:txBody>
-                  <a:tcPr marL="91440" marR="91440" marT="45720" marB="45720" anchor="ctr">
+                  <a:tcPr anchor="ctr">
                     <a:lnL w="12700" cap="flat" cmpd="sng" algn="ctr">
                       <a:solidFill>
                         <a:srgbClr val="E2E8F0"/>
@@ -2784,7 +3140,7 @@
                     <a:bodyPr/>
                     <a:lstStyle/>
                     <a:p>
-                      <a:pPr algn="ctr" indent="0" marL="0">
+                      <a:pPr marL="0" indent="0" algn="ctr">
                         <a:buNone/>
                       </a:pPr>
                       <a:r>
@@ -2798,7 +3154,7 @@
                       <a:endParaRPr lang="en-US" sz="1400" dirty="0"/>
                     </a:p>
                   </a:txBody>
-                  <a:tcPr marL="91440" marR="91440" marT="45720" marB="45720" anchor="ctr">
+                  <a:tcPr anchor="ctr">
                     <a:lnL w="12700" cap="flat" cmpd="sng" algn="ctr">
                       <a:solidFill>
                         <a:srgbClr val="E2E8F0"/>
@@ -2845,7 +3201,7 @@
                     <a:bodyPr/>
                     <a:lstStyle/>
                     <a:p>
-                      <a:pPr algn="ctr" indent="0" marL="0">
+                      <a:pPr marL="0" indent="0" algn="ctr">
                         <a:buNone/>
                       </a:pPr>
                       <a:r>
@@ -2854,12 +3210,12 @@
                             <a:srgbClr val="000000"/>
                           </a:solidFill>
                         </a:rPr>
-                        <a:t>Voted in for 5+ lunch sessions</a:t>
+                        <a:t>Voted in for 10+ lunch sessions</a:t>
                       </a:r>
                       <a:endParaRPr lang="en-US" sz="1400" dirty="0"/>
                     </a:p>
                   </a:txBody>
-                  <a:tcPr marL="91440" marR="91440" marT="45720" marB="45720" anchor="ctr">
+                  <a:tcPr anchor="ctr">
                     <a:lnL w="12700" cap="flat" cmpd="sng" algn="ctr">
                       <a:solidFill>
                         <a:srgbClr val="E2E8F0"/>
@@ -2901,6 +3257,11 @@
                     </a:solidFill>
                   </a:tcPr>
                 </a:tc>
+                <a:extLst>
+                  <a:ext uri="{0D108BD9-81ED-4DB2-BD59-A6C34878D82A}">
+                    <a16:rowId xmlns:a16="http://schemas.microsoft.com/office/drawing/2014/main" val="10001"/>
+                  </a:ext>
+                </a:extLst>
               </a:tr>
               <a:tr h="571500">
                 <a:tc>
@@ -2908,7 +3269,7 @@
                     <a:bodyPr/>
                     <a:lstStyle/>
                     <a:p>
-                      <a:pPr algn="ctr" indent="0" marL="0">
+                      <a:pPr marL="0" indent="0" algn="ctr">
                         <a:buNone/>
                       </a:pPr>
                       <a:r>
@@ -2922,7 +3283,7 @@
                       <a:endParaRPr lang="en-US" sz="1400" dirty="0"/>
                     </a:p>
                   </a:txBody>
-                  <a:tcPr marL="91440" marR="91440" marT="45720" marB="45720" anchor="ctr">
+                  <a:tcPr anchor="ctr">
                     <a:lnL w="12700" cap="flat" cmpd="sng" algn="ctr">
                       <a:solidFill>
                         <a:srgbClr val="E2E8F0"/>
@@ -2969,7 +3330,7 @@
                     <a:bodyPr/>
                     <a:lstStyle/>
                     <a:p>
-                      <a:pPr algn="ctr" indent="0" marL="0">
+                      <a:pPr marL="0" indent="0" algn="ctr">
                         <a:buNone/>
                       </a:pPr>
                       <a:r>
@@ -2983,7 +3344,7 @@
                       <a:endParaRPr lang="en-US" sz="1400" dirty="0"/>
                     </a:p>
                   </a:txBody>
-                  <a:tcPr marL="91440" marR="91440" marT="45720" marB="45720" anchor="ctr">
+                  <a:tcPr anchor="ctr">
                     <a:lnL w="12700" cap="flat" cmpd="sng" algn="ctr">
                       <a:solidFill>
                         <a:srgbClr val="E2E8F0"/>
@@ -3030,7 +3391,7 @@
                     <a:bodyPr/>
                     <a:lstStyle/>
                     <a:p>
-                      <a:pPr algn="ctr" indent="0" marL="0">
+                      <a:pPr marL="0" indent="0" algn="ctr">
                         <a:buNone/>
                       </a:pPr>
                       <a:r>
@@ -3044,7 +3405,7 @@
                       <a:endParaRPr lang="en-US" sz="1400" dirty="0"/>
                     </a:p>
                   </a:txBody>
-                  <a:tcPr marL="91440" marR="91440" marT="45720" marB="45720" anchor="ctr">
+                  <a:tcPr anchor="ctr">
                     <a:lnL w="12700" cap="flat" cmpd="sng" algn="ctr">
                       <a:solidFill>
                         <a:srgbClr val="E2E8F0"/>
@@ -3086,6 +3447,11 @@
                     </a:solidFill>
                   </a:tcPr>
                 </a:tc>
+                <a:extLst>
+                  <a:ext uri="{0D108BD9-81ED-4DB2-BD59-A6C34878D82A}">
+                    <a16:rowId xmlns:a16="http://schemas.microsoft.com/office/drawing/2014/main" val="10002"/>
+                  </a:ext>
+                </a:extLst>
               </a:tr>
               <a:tr h="571500">
                 <a:tc>
@@ -3093,7 +3459,7 @@
                     <a:bodyPr/>
                     <a:lstStyle/>
                     <a:p>
-                      <a:pPr algn="ctr" indent="0" marL="0">
+                      <a:pPr marL="0" indent="0" algn="ctr">
                         <a:buNone/>
                       </a:pPr>
                       <a:r>
@@ -3102,12 +3468,12 @@
                             <a:srgbClr val="000000"/>
                           </a:solidFill>
                         </a:rPr>
-                        <a:t>🥉 Lunch Padawon</a:t>
+                        <a:t>🥉 Lunch Padawan</a:t>
                       </a:r>
                       <a:endParaRPr lang="en-US" sz="1400" dirty="0"/>
                     </a:p>
                   </a:txBody>
-                  <a:tcPr marL="91440" marR="91440" marT="45720" marB="45720" anchor="ctr">
+                  <a:tcPr anchor="ctr">
                     <a:lnL w="12700" cap="flat" cmpd="sng" algn="ctr">
                       <a:solidFill>
                         <a:srgbClr val="E2E8F0"/>
@@ -3154,7 +3520,7 @@
                     <a:bodyPr/>
                     <a:lstStyle/>
                     <a:p>
-                      <a:pPr algn="ctr" indent="0" marL="0">
+                      <a:pPr marL="0" indent="0" algn="ctr">
                         <a:buNone/>
                       </a:pPr>
                       <a:r>
@@ -3168,7 +3534,7 @@
                       <a:endParaRPr lang="en-US" sz="1400" dirty="0"/>
                     </a:p>
                   </a:txBody>
-                  <a:tcPr marL="91440" marR="91440" marT="45720" marB="45720" anchor="ctr">
+                  <a:tcPr anchor="ctr">
                     <a:lnL w="12700" cap="flat" cmpd="sng" algn="ctr">
                       <a:solidFill>
                         <a:srgbClr val="E2E8F0"/>
@@ -3215,7 +3581,7 @@
                     <a:bodyPr/>
                     <a:lstStyle/>
                     <a:p>
-                      <a:pPr algn="ctr" indent="0" marL="0">
+                      <a:pPr marL="0" indent="0" algn="ctr">
                         <a:buNone/>
                       </a:pPr>
                       <a:r>
@@ -3229,7 +3595,7 @@
                       <a:endParaRPr lang="en-US" sz="1400" dirty="0"/>
                     </a:p>
                   </a:txBody>
-                  <a:tcPr marL="91440" marR="91440" marT="45720" marB="45720" anchor="ctr">
+                  <a:tcPr anchor="ctr">
                     <a:lnL w="12700" cap="flat" cmpd="sng" algn="ctr">
                       <a:solidFill>
                         <a:srgbClr val="E2E8F0"/>
@@ -3271,6 +3637,11 @@
                     </a:solidFill>
                   </a:tcPr>
                 </a:tc>
+                <a:extLst>
+                  <a:ext uri="{0D108BD9-81ED-4DB2-BD59-A6C34878D82A}">
+                    <a16:rowId xmlns:a16="http://schemas.microsoft.com/office/drawing/2014/main" val="10003"/>
+                  </a:ext>
+                </a:extLst>
               </a:tr>
             </a:tbl>
           </a:graphicData>
@@ -3297,7 +3668,7 @@
           <a:bodyPr wrap="square" rtlCol="0" anchor="ctr"/>
           <a:lstStyle/>
           <a:p>
-            <a:pPr indent="0" marL="0">
+            <a:pPr marL="0" indent="0">
               <a:buNone/>
             </a:pPr>
             <a:r>
@@ -3320,7 +3691,7 @@
 </p:sld>
 </file>
 
-<file path=ppt/slides/slide5.xml><?xml version="1.0" encoding="utf-8"?>
+<file path=ppt/slides/slide6.xml><?xml version="1.0" encoding="utf-8"?>
 <p:sld xmlns:a="http://schemas.openxmlformats.org/drawingml/2006/main" xmlns:r="http://schemas.openxmlformats.org/officeDocument/2006/relationships" xmlns:p="http://schemas.openxmlformats.org/presentationml/2006/main">
   <p:cSld name="Slide 5">
     <p:bg>
@@ -3328,6 +3699,7 @@
         <a:solidFill>
           <a:srgbClr val="F3F4F6"/>
         </a:solidFill>
+        <a:effectLst/>
       </p:bgPr>
     </p:bg>
     <p:spTree>
@@ -3385,7 +3757,7 @@
           <a:bodyPr wrap="square" rtlCol="0" anchor="ctr"/>
           <a:lstStyle/>
           <a:p>
-            <a:pPr indent="0" marL="0">
+            <a:pPr marL="0" indent="0">
               <a:buNone/>
             </a:pPr>
             <a:r>
@@ -3415,9 +3787,7 @@
             <a:ext cx="2743200" cy="548640"/>
           </a:xfrm>
           <a:prstGeom prst="rect">
-            <a:avLst>
-              <a:gd name="adj" fmla="val 8333"/>
-            </a:avLst>
+            <a:avLst/>
           </a:prstGeom>
           <a:solidFill>
             <a:srgbClr val="3776AB"/>
@@ -3446,7 +3816,7 @@
           <a:bodyPr wrap="square" rtlCol="0" anchor="ctr"/>
           <a:lstStyle/>
           <a:p>
-            <a:pPr algn="ctr" indent="0" marL="0">
+            <a:pPr marL="0" indent="0" algn="ctr">
               <a:buNone/>
             </a:pPr>
             <a:r>
@@ -3458,7 +3828,7 @@
                 <a:ea typeface="Arial Black" pitchFamily="34" charset="-122"/>
                 <a:cs typeface="Arial Black" pitchFamily="34" charset="-120"/>
               </a:rPr>
-              <a:t>Python Core</a:t>
+              <a:t>AI-Driven Core</a:t>
             </a:r>
             <a:endParaRPr lang="en-US" sz="1800" dirty="0"/>
           </a:p>
@@ -3508,7 +3878,7 @@
           <a:bodyPr wrap="square" rtlCol="0" anchor="ctr"/>
           <a:lstStyle/>
           <a:p>
-            <a:pPr indent="0" marL="0">
+            <a:pPr marL="0" indent="0">
               <a:buNone/>
             </a:pPr>
             <a:r>
@@ -3517,7 +3887,7 @@
                   <a:srgbClr val="1E293B"/>
                 </a:solidFill>
               </a:rPr>
-              <a:t>Business Logic &amp; API handling</a:t>
+              <a:t>Gemini 3.1 Hype-Bot &amp; API Logic</a:t>
             </a:r>
             <a:endParaRPr lang="en-US" sz="1600" dirty="0"/>
           </a:p>
@@ -3535,9 +3905,7 @@
             <a:ext cx="2743200" cy="548640"/>
           </a:xfrm>
           <a:prstGeom prst="rect">
-            <a:avLst>
-              <a:gd name="adj" fmla="val 8333"/>
-            </a:avLst>
+            <a:avLst/>
           </a:prstGeom>
           <a:solidFill>
             <a:srgbClr val="000000"/>
@@ -3566,7 +3934,7 @@
           <a:bodyPr wrap="square" rtlCol="0" anchor="ctr"/>
           <a:lstStyle/>
           <a:p>
-            <a:pPr algn="ctr" indent="0" marL="0">
+            <a:pPr marL="0" indent="0" algn="ctr">
               <a:buNone/>
             </a:pPr>
             <a:r>
@@ -3628,7 +3996,7 @@
           <a:bodyPr wrap="square" rtlCol="0" anchor="ctr"/>
           <a:lstStyle/>
           <a:p>
-            <a:pPr indent="0" marL="0">
+            <a:pPr marL="0" indent="0">
               <a:buNone/>
             </a:pPr>
             <a:r>
@@ -3655,9 +4023,7 @@
             <a:ext cx="2743200" cy="548640"/>
           </a:xfrm>
           <a:prstGeom prst="rect">
-            <a:avLst>
-              <a:gd name="adj" fmla="val 8333"/>
-            </a:avLst>
+            <a:avLst/>
           </a:prstGeom>
           <a:solidFill>
             <a:srgbClr val="FF4B4B"/>
@@ -3686,7 +4052,7 @@
           <a:bodyPr wrap="square" rtlCol="0" anchor="ctr"/>
           <a:lstStyle/>
           <a:p>
-            <a:pPr algn="ctr" indent="0" marL="0">
+            <a:pPr marL="0" indent="0" algn="ctr">
               <a:buNone/>
             </a:pPr>
             <a:r>
@@ -3748,7 +4114,7 @@
           <a:bodyPr wrap="square" rtlCol="0" anchor="ctr"/>
           <a:lstStyle/>
           <a:p>
-            <a:pPr indent="0" marL="0">
+            <a:pPr marL="0" indent="0">
               <a:buNone/>
             </a:pPr>
             <a:r>
@@ -3775,9 +4141,7 @@
             <a:ext cx="2743200" cy="548640"/>
           </a:xfrm>
           <a:prstGeom prst="rect">
-            <a:avLst>
-              <a:gd name="adj" fmla="val 8333"/>
-            </a:avLst>
+            <a:avLst/>
           </a:prstGeom>
           <a:solidFill>
             <a:srgbClr val="2088FF"/>
@@ -3806,7 +4170,7 @@
           <a:bodyPr wrap="square" rtlCol="0" anchor="ctr"/>
           <a:lstStyle/>
           <a:p>
-            <a:pPr algn="ctr" indent="0" marL="0">
+            <a:pPr marL="0" indent="0" algn="ctr">
               <a:buNone/>
             </a:pPr>
             <a:r>
@@ -3868,7 +4232,7 @@
           <a:bodyPr wrap="square" rtlCol="0" anchor="ctr"/>
           <a:lstStyle/>
           <a:p>
-            <a:pPr indent="0" marL="0">
+            <a:pPr marL="0" indent="0">
               <a:buNone/>
             </a:pPr>
             <a:r>
@@ -4184,4 +4548,299 @@
     </a:ext>
   </a:extLst>
 </a:theme>
+</file>
+
+<file path=ppt/theme/theme2.xml><?xml version="1.0" encoding="utf-8"?>
+<a:theme xmlns:a="http://schemas.openxmlformats.org/drawingml/2006/main" name="Office Theme">
+  <a:themeElements>
+    <a:clrScheme name="Office">
+      <a:dk1>
+        <a:sysClr val="windowText" lastClr="000000"/>
+      </a:dk1>
+      <a:lt1>
+        <a:sysClr val="window" lastClr="FFFFFF"/>
+      </a:lt1>
+      <a:dk2>
+        <a:srgbClr val="44546A"/>
+      </a:dk2>
+      <a:lt2>
+        <a:srgbClr val="E7E6E6"/>
+      </a:lt2>
+      <a:accent1>
+        <a:srgbClr val="4472C4"/>
+      </a:accent1>
+      <a:accent2>
+        <a:srgbClr val="ED7D31"/>
+      </a:accent2>
+      <a:accent3>
+        <a:srgbClr val="A5A5A5"/>
+      </a:accent3>
+      <a:accent4>
+        <a:srgbClr val="FFC000"/>
+      </a:accent4>
+      <a:accent5>
+        <a:srgbClr val="5B9BD5"/>
+      </a:accent5>
+      <a:accent6>
+        <a:srgbClr val="70AD47"/>
+      </a:accent6>
+      <a:hlink>
+        <a:srgbClr val="0563C1"/>
+      </a:hlink>
+      <a:folHlink>
+        <a:srgbClr val="954F72"/>
+      </a:folHlink>
+    </a:clrScheme>
+    <a:fontScheme name="Office">
+      <a:majorFont>
+        <a:latin typeface="Calibri Light" panose="020F0302020204030204"/>
+        <a:ea typeface=""/>
+        <a:cs typeface=""/>
+        <a:font script="Jpan" typeface="游ゴシック Light"/>
+        <a:font script="Hang" typeface="맑은 고딕"/>
+        <a:font script="Hans" typeface="等线 Light"/>
+        <a:font script="Hant" typeface="新細明體"/>
+        <a:font script="Arab" typeface="Times New Roman"/>
+        <a:font script="Hebr" typeface="Times New Roman"/>
+        <a:font script="Thai" typeface="Angsana New"/>
+        <a:font script="Ethi" typeface="Nyala"/>
+        <a:font script="Beng" typeface="Vrinda"/>
+        <a:font script="Gujr" typeface="Shruti"/>
+        <a:font script="Khmr" typeface="MoolBoran"/>
+        <a:font script="Knda" typeface="Tunga"/>
+        <a:font script="Guru" typeface="Raavi"/>
+        <a:font script="Cans" typeface="Euphemia"/>
+        <a:font script="Cher" typeface="Plantagenet Cherokee"/>
+        <a:font script="Yiii" typeface="Microsoft Yi Baiti"/>
+        <a:font script="Tibt" typeface="Microsoft Himalaya"/>
+        <a:font script="Thaa" typeface="MV Boli"/>
+        <a:font script="Deva" typeface="Mangal"/>
+        <a:font script="Telu" typeface="Gautami"/>
+        <a:font script="Taml" typeface="Latha"/>
+        <a:font script="Syrc" typeface="Estrangelo Edessa"/>
+        <a:font script="Orya" typeface="Kalinga"/>
+        <a:font script="Mlym" typeface="Kartika"/>
+        <a:font script="Laoo" typeface="DokChampa"/>
+        <a:font script="Sinh" typeface="Iskoola Pota"/>
+        <a:font script="Mong" typeface="Mongolian Baiti"/>
+        <a:font script="Viet" typeface="Times New Roman"/>
+        <a:font script="Uigh" typeface="Microsoft Uighur"/>
+        <a:font script="Geor" typeface="Sylfaen"/>
+        <a:font script="Armn" typeface="Arial"/>
+        <a:font script="Bugi" typeface="Leelawadee UI"/>
+        <a:font script="Bopo" typeface="Microsoft JhengHei"/>
+        <a:font script="Java" typeface="Javanese Text"/>
+        <a:font script="Lisu" typeface="Segoe UI"/>
+        <a:font script="Mymr" typeface="Myanmar Text"/>
+        <a:font script="Nkoo" typeface="Ebrima"/>
+        <a:font script="Olck" typeface="Nirmala UI"/>
+        <a:font script="Osma" typeface="Ebrima"/>
+        <a:font script="Phag" typeface="Phagspa"/>
+        <a:font script="Syrn" typeface="Estrangelo Edessa"/>
+        <a:font script="Syrj" typeface="Estrangelo Edessa"/>
+        <a:font script="Syre" typeface="Estrangelo Edessa"/>
+        <a:font script="Sora" typeface="Nirmala UI"/>
+        <a:font script="Tale" typeface="Microsoft Tai Le"/>
+        <a:font script="Talu" typeface="Microsoft New Tai Lue"/>
+        <a:font script="Tfng" typeface="Ebrima"/>
+      </a:majorFont>
+      <a:minorFont>
+        <a:latin typeface="Calibri" panose="020F0502020204030204"/>
+        <a:ea typeface=""/>
+        <a:cs typeface=""/>
+        <a:font script="Jpan" typeface="游ゴシック"/>
+        <a:font script="Hang" typeface="맑은 고딕"/>
+        <a:font script="Hans" typeface="等线"/>
+        <a:font script="Hant" typeface="新細明體"/>
+        <a:font script="Arab" typeface="Arial"/>
+        <a:font script="Hebr" typeface="Arial"/>
+        <a:font script="Thai" typeface="Cordia New"/>
+        <a:font script="Ethi" typeface="Nyala"/>
+        <a:font script="Beng" typeface="Vrinda"/>
+        <a:font script="Gujr" typeface="Shruti"/>
+        <a:font script="Khmr" typeface="DaunPenh"/>
+        <a:font script="Knda" typeface="Tunga"/>
+        <a:font script="Guru" typeface="Raavi"/>
+        <a:font script="Cans" typeface="Euphemia"/>
+        <a:font script="Cher" typeface="Plantagenet Cherokee"/>
+        <a:font script="Yiii" typeface="Microsoft Yi Baiti"/>
+        <a:font script="Tibt" typeface="Microsoft Himalaya"/>
+        <a:font script="Thaa" typeface="MV Boli"/>
+        <a:font script="Deva" typeface="Mangal"/>
+        <a:font script="Telu" typeface="Gautami"/>
+        <a:font script="Taml" typeface="Latha"/>
+        <a:font script="Syrc" typeface="Estrangelo Edessa"/>
+        <a:font script="Orya" typeface="Kalinga"/>
+        <a:font script="Mlym" typeface="Kartika"/>
+        <a:font script="Laoo" typeface="DokChampa"/>
+        <a:font script="Sinh" typeface="Iskoola Pota"/>
+        <a:font script="Mong" typeface="Mongolian Baiti"/>
+        <a:font script="Viet" typeface="Arial"/>
+        <a:font script="Uigh" typeface="Microsoft Uighur"/>
+        <a:font script="Geor" typeface="Sylfaen"/>
+        <a:font script="Armn" typeface="Arial"/>
+        <a:font script="Bugi" typeface="Leelawadee UI"/>
+        <a:font script="Bopo" typeface="Microsoft JhengHei"/>
+        <a:font script="Java" typeface="Javanese Text"/>
+        <a:font script="Lisu" typeface="Segoe UI"/>
+        <a:font script="Mymr" typeface="Myanmar Text"/>
+        <a:font script="Nkoo" typeface="Ebrima"/>
+        <a:font script="Olck" typeface="Nirmala UI"/>
+        <a:font script="Osma" typeface="Ebrima"/>
+        <a:font script="Phag" typeface="Phagspa"/>
+        <a:font script="Syrn" typeface="Estrangelo Edessa"/>
+        <a:font script="Syrj" typeface="Estrangelo Edessa"/>
+        <a:font script="Syre" typeface="Estrangelo Edessa"/>
+        <a:font script="Sora" typeface="Nirmala UI"/>
+        <a:font script="Tale" typeface="Microsoft Tai Le"/>
+        <a:font script="Talu" typeface="Microsoft New Tai Lue"/>
+        <a:font script="Tfng" typeface="Ebrima"/>
+      </a:minorFont>
+    </a:fontScheme>
+    <a:fmtScheme name="Office">
+      <a:fillStyleLst>
+        <a:solidFill>
+          <a:schemeClr val="phClr"/>
+        </a:solidFill>
+        <a:gradFill rotWithShape="1">
+          <a:gsLst>
+            <a:gs pos="0">
+              <a:schemeClr val="phClr">
+                <a:lumMod val="110000"/>
+                <a:satMod val="105000"/>
+                <a:tint val="67000"/>
+              </a:schemeClr>
+            </a:gs>
+            <a:gs pos="50000">
+              <a:schemeClr val="phClr">
+                <a:lumMod val="105000"/>
+                <a:satMod val="103000"/>
+                <a:tint val="73000"/>
+              </a:schemeClr>
+            </a:gs>
+            <a:gs pos="100000">
+              <a:schemeClr val="phClr">
+                <a:lumMod val="105000"/>
+                <a:satMod val="109000"/>
+                <a:tint val="81000"/>
+              </a:schemeClr>
+            </a:gs>
+          </a:gsLst>
+          <a:lin ang="5400000" scaled="0"/>
+        </a:gradFill>
+        <a:gradFill rotWithShape="1">
+          <a:gsLst>
+            <a:gs pos="0">
+              <a:schemeClr val="phClr">
+                <a:satMod val="103000"/>
+                <a:lumMod val="102000"/>
+                <a:tint val="94000"/>
+              </a:schemeClr>
+            </a:gs>
+            <a:gs pos="50000">
+              <a:schemeClr val="phClr">
+                <a:satMod val="110000"/>
+                <a:lumMod val="100000"/>
+                <a:shade val="100000"/>
+              </a:schemeClr>
+            </a:gs>
+            <a:gs pos="100000">
+              <a:schemeClr val="phClr">
+                <a:lumMod val="99000"/>
+                <a:satMod val="120000"/>
+                <a:shade val="78000"/>
+              </a:schemeClr>
+            </a:gs>
+          </a:gsLst>
+          <a:lin ang="5400000" scaled="0"/>
+        </a:gradFill>
+      </a:fillStyleLst>
+      <a:lnStyleLst>
+        <a:ln w="6350" cap="flat" cmpd="sng" algn="ctr">
+          <a:solidFill>
+            <a:schemeClr val="phClr"/>
+          </a:solidFill>
+          <a:prstDash val="solid"/>
+          <a:miter lim="800000"/>
+        </a:ln>
+        <a:ln w="12700" cap="flat" cmpd="sng" algn="ctr">
+          <a:solidFill>
+            <a:schemeClr val="phClr"/>
+          </a:solidFill>
+          <a:prstDash val="solid"/>
+          <a:miter lim="800000"/>
+        </a:ln>
+        <a:ln w="19050" cap="flat" cmpd="sng" algn="ctr">
+          <a:solidFill>
+            <a:schemeClr val="phClr"/>
+          </a:solidFill>
+          <a:prstDash val="solid"/>
+          <a:miter lim="800000"/>
+        </a:ln>
+      </a:lnStyleLst>
+      <a:effectStyleLst>
+        <a:effectStyle>
+          <a:effectLst/>
+        </a:effectStyle>
+        <a:effectStyle>
+          <a:effectLst/>
+        </a:effectStyle>
+        <a:effectStyle>
+          <a:effectLst>
+            <a:outerShdw blurRad="57150" dist="19050" dir="5400000" algn="ctr" rotWithShape="0">
+              <a:srgbClr val="000000">
+                <a:alpha val="63000"/>
+              </a:srgbClr>
+            </a:outerShdw>
+          </a:effectLst>
+        </a:effectStyle>
+      </a:effectStyleLst>
+      <a:bgFillStyleLst>
+        <a:solidFill>
+          <a:schemeClr val="phClr"/>
+        </a:solidFill>
+        <a:solidFill>
+          <a:schemeClr val="phClr">
+            <a:tint val="95000"/>
+            <a:satMod val="170000"/>
+          </a:schemeClr>
+        </a:solidFill>
+        <a:gradFill rotWithShape="1">
+          <a:gsLst>
+            <a:gs pos="0">
+              <a:schemeClr val="phClr">
+                <a:tint val="93000"/>
+                <a:satMod val="150000"/>
+                <a:shade val="98000"/>
+                <a:lumMod val="102000"/>
+              </a:schemeClr>
+            </a:gs>
+            <a:gs pos="50000">
+              <a:schemeClr val="phClr">
+                <a:tint val="98000"/>
+                <a:satMod val="130000"/>
+                <a:shade val="90000"/>
+                <a:lumMod val="103000"/>
+              </a:schemeClr>
+            </a:gs>
+            <a:gs pos="100000">
+              <a:schemeClr val="phClr">
+                <a:shade val="63000"/>
+                <a:satMod val="120000"/>
+              </a:schemeClr>
+            </a:gs>
+          </a:gsLst>
+          <a:lin ang="5400000" scaled="0"/>
+        </a:gradFill>
+      </a:bgFillStyleLst>
+    </a:fmtScheme>
+  </a:themeElements>
+  <a:objectDefaults/>
+  <a:extraClrSchemeLst/>
+  <a:extLst>
+    <a:ext uri="{05A4C25C-085E-4340-85A3-A5531E510DB2}">
+      <thm15:themeFamily xmlns:thm15="http://schemas.microsoft.com/office/thememl/2012/main" name="Office Theme" id="{62F939B6-93AF-4DB8-9C6B-D6C7DFDC589F}" vid="{4A3C46E8-61CC-4603-A589-7422A47A8E4A}"/>
+    </a:ext>
+  </a:extLst>
+</a:theme>
 </file>
</xml_diff>